<commit_message>
Remove presentation meta wording
</commit_message>
<xml_diff>
--- a/docs/zh/10-Claude Code 源码调研.pptx
+++ b/docs/zh/10-Claude Code 源码调研.pptx
@@ -3408,7 +3408,7 @@
                 </a:solidFill>
                 <a:latin typeface="Arial"/>
               </a:rPr>
-              <a:t>这场分享要解决什么</a:t>
+              <a:t>调研目标</a:t>
             </a:r>
           </a:p>
         </p:txBody>
@@ -3576,7 +3576,7 @@
                 </a:solidFill>
                 <a:latin typeface="Arial"/>
               </a:rPr>
-              <a:t>这场分享怎么讲</a:t>
+              <a:t>调研范围</a:t>
             </a:r>
           </a:p>
         </p:txBody>
@@ -3744,7 +3744,7 @@
                 </a:solidFill>
                 <a:latin typeface="Arial"/>
               </a:rPr>
-              <a:t>核心判断</a:t>
+              <a:t>调研结论</a:t>
             </a:r>
           </a:p>
         </p:txBody>
@@ -5437,7 +5437,7 @@
                 </a:solidFill>
                 <a:latin typeface="Arial"/>
               </a:rPr>
-              <a:t>实现逻辑</a:t>
+              <a:t>实现含义</a:t>
             </a:r>
           </a:p>
         </p:txBody>
@@ -5573,7 +5573,7 @@
                 </a:solidFill>
                 <a:latin typeface="Arial"/>
               </a:rPr>
-              <a:t>相关模块</a:t>
+              <a:t>相关代码</a:t>
             </a:r>
           </a:p>
         </p:txBody>
@@ -5709,7 +5709,7 @@
                 </a:solidFill>
                 <a:latin typeface="Arial"/>
               </a:rPr>
-              <a:t>关键结论</a:t>
+              <a:t>调研结论</a:t>
             </a:r>
           </a:p>
         </p:txBody>
@@ -6328,7 +6328,7 @@
                 </a:solidFill>
                 <a:latin typeface="Arial"/>
               </a:rPr>
-              <a:t>实现逻辑</a:t>
+              <a:t>实现含义</a:t>
             </a:r>
           </a:p>
         </p:txBody>
@@ -6464,7 +6464,7 @@
                 </a:solidFill>
                 <a:latin typeface="Arial"/>
               </a:rPr>
-              <a:t>相关模块</a:t>
+              <a:t>相关代码</a:t>
             </a:r>
           </a:p>
         </p:txBody>
@@ -6600,7 +6600,7 @@
                 </a:solidFill>
                 <a:latin typeface="Arial"/>
               </a:rPr>
-              <a:t>关键结论</a:t>
+              <a:t>调研结论</a:t>
             </a:r>
           </a:p>
         </p:txBody>
@@ -7207,7 +7207,7 @@
                 </a:solidFill>
                 <a:latin typeface="Arial"/>
               </a:rPr>
-              <a:t>实现逻辑</a:t>
+              <a:t>实现含义</a:t>
             </a:r>
           </a:p>
         </p:txBody>
@@ -7343,7 +7343,7 @@
                 </a:solidFill>
                 <a:latin typeface="Arial"/>
               </a:rPr>
-              <a:t>相关模块</a:t>
+              <a:t>相关代码</a:t>
             </a:r>
           </a:p>
         </p:txBody>
@@ -7495,7 +7495,7 @@
                 </a:solidFill>
                 <a:latin typeface="Arial"/>
               </a:rPr>
-              <a:t>关键结论</a:t>
+              <a:t>调研结论</a:t>
             </a:r>
           </a:p>
         </p:txBody>
@@ -8130,7 +8130,7 @@
                 </a:solidFill>
                 <a:latin typeface="Arial"/>
               </a:rPr>
-              <a:t>实现逻辑</a:t>
+              <a:t>实现含义</a:t>
             </a:r>
           </a:p>
         </p:txBody>
@@ -8266,7 +8266,7 @@
                 </a:solidFill>
                 <a:latin typeface="Arial"/>
               </a:rPr>
-              <a:t>相关模块</a:t>
+              <a:t>相关代码</a:t>
             </a:r>
           </a:p>
         </p:txBody>
@@ -8402,7 +8402,7 @@
                 </a:solidFill>
                 <a:latin typeface="Arial"/>
               </a:rPr>
-              <a:t>关键结论</a:t>
+              <a:t>调研结论</a:t>
             </a:r>
           </a:p>
         </p:txBody>
@@ -8973,7 +8973,7 @@
                 </a:solidFill>
                 <a:latin typeface="Arial"/>
               </a:rPr>
-              <a:t>实现逻辑</a:t>
+              <a:t>实现含义</a:t>
             </a:r>
           </a:p>
         </p:txBody>
@@ -9109,7 +9109,7 @@
                 </a:solidFill>
                 <a:latin typeface="Arial"/>
               </a:rPr>
-              <a:t>相关模块</a:t>
+              <a:t>相关代码</a:t>
             </a:r>
           </a:p>
         </p:txBody>
@@ -9277,7 +9277,7 @@
                 </a:solidFill>
                 <a:latin typeface="Arial"/>
               </a:rPr>
-              <a:t>关键结论</a:t>
+              <a:t>调研结论</a:t>
             </a:r>
           </a:p>
         </p:txBody>
@@ -9832,7 +9832,7 @@
                 </a:solidFill>
                 <a:latin typeface="Arial"/>
               </a:rPr>
-              <a:t>实现逻辑</a:t>
+              <a:t>实现含义</a:t>
             </a:r>
           </a:p>
         </p:txBody>
@@ -9871,7 +9871,7 @@
                 </a:solidFill>
                 <a:latin typeface="Arial"/>
               </a:rPr>
-              <a:t>这页主要是概览，不强行上代码块。</a:t>
+              <a:t>本页重点在于建立整体理解，而不是展开单段代码。</a:t>
             </a:r>
           </a:p>
         </p:txBody>
@@ -9968,7 +9968,7 @@
                 </a:solidFill>
                 <a:latin typeface="Arial"/>
               </a:rPr>
-              <a:t>相关模块</a:t>
+              <a:t>相关代码</a:t>
             </a:r>
           </a:p>
         </p:txBody>
@@ -10104,7 +10104,7 @@
                 </a:solidFill>
                 <a:latin typeface="Arial"/>
               </a:rPr>
-              <a:t>关键结论</a:t>
+              <a:t>调研结论</a:t>
             </a:r>
           </a:p>
         </p:txBody>
@@ -11551,7 +11551,7 @@
                 </a:solidFill>
                 <a:latin typeface="Arial"/>
               </a:rPr>
-              <a:t>关键结论</a:t>
+              <a:t>调研结论</a:t>
             </a:r>
           </a:p>
         </p:txBody>
@@ -12218,7 +12218,7 @@
                 </a:solidFill>
                 <a:latin typeface="Arial"/>
               </a:rPr>
-              <a:t>实现逻辑</a:t>
+              <a:t>实现含义</a:t>
             </a:r>
           </a:p>
         </p:txBody>
@@ -12354,7 +12354,7 @@
                 </a:solidFill>
                 <a:latin typeface="Arial"/>
               </a:rPr>
-              <a:t>相关模块</a:t>
+              <a:t>相关代码</a:t>
             </a:r>
           </a:p>
         </p:txBody>
@@ -12490,7 +12490,7 @@
                 </a:solidFill>
                 <a:latin typeface="Arial"/>
               </a:rPr>
-              <a:t>关键结论</a:t>
+              <a:t>调研结论</a:t>
             </a:r>
           </a:p>
         </p:txBody>
@@ -13395,7 +13395,7 @@
                 </a:solidFill>
                 <a:latin typeface="Arial"/>
               </a:rPr>
-              <a:t>关键结论</a:t>
+              <a:t>调研结论</a:t>
             </a:r>
           </a:p>
         </p:txBody>
@@ -13966,7 +13966,7 @@
                 </a:solidFill>
                 <a:latin typeface="Arial"/>
               </a:rPr>
-              <a:t>实现逻辑</a:t>
+              <a:t>实现含义</a:t>
             </a:r>
           </a:p>
         </p:txBody>
@@ -14005,7 +14005,7 @@
                 </a:solidFill>
                 <a:latin typeface="Arial"/>
               </a:rPr>
-              <a:t>这页主要是概览，不强行上代码块。</a:t>
+              <a:t>本页重点在于建立整体理解，而不是展开单段代码。</a:t>
             </a:r>
           </a:p>
         </p:txBody>
@@ -14102,7 +14102,7 @@
                 </a:solidFill>
                 <a:latin typeface="Arial"/>
               </a:rPr>
-              <a:t>相关模块</a:t>
+              <a:t>相关代码</a:t>
             </a:r>
           </a:p>
         </p:txBody>
@@ -14238,7 +14238,7 @@
                 </a:solidFill>
                 <a:latin typeface="Arial"/>
               </a:rPr>
-              <a:t>关键结论</a:t>
+              <a:t>调研结论</a:t>
             </a:r>
           </a:p>
         </p:txBody>
@@ -14277,7 +14277,7 @@
                 </a:solidFill>
                 <a:latin typeface="Arial"/>
               </a:rPr>
-              <a:t>这场分享的目标不是“理解全部源码”，而是“理解到足够会用”。</a:t>
+              <a:t>本次调研不追求覆盖全部源码，而是提炼到足够指导使用的理解。</a:t>
             </a:r>
           </a:p>
         </p:txBody>
@@ -14893,7 +14893,7 @@
                 </a:solidFill>
                 <a:latin typeface="Arial"/>
               </a:rPr>
-              <a:t>实现逻辑</a:t>
+              <a:t>实现含义</a:t>
             </a:r>
           </a:p>
         </p:txBody>
@@ -15029,7 +15029,7 @@
                 </a:solidFill>
                 <a:latin typeface="Arial"/>
               </a:rPr>
-              <a:t>相关模块</a:t>
+              <a:t>相关代码</a:t>
             </a:r>
           </a:p>
         </p:txBody>
@@ -15213,7 +15213,7 @@
                 </a:solidFill>
                 <a:latin typeface="Arial"/>
               </a:rPr>
-              <a:t>关键结论</a:t>
+              <a:t>调研结论</a:t>
             </a:r>
           </a:p>
         </p:txBody>
@@ -15880,7 +15880,7 @@
                 </a:solidFill>
                 <a:latin typeface="Arial"/>
               </a:rPr>
-              <a:t>实现逻辑</a:t>
+              <a:t>实现含义</a:t>
             </a:r>
           </a:p>
         </p:txBody>
@@ -16016,7 +16016,7 @@
                 </a:solidFill>
                 <a:latin typeface="Arial"/>
               </a:rPr>
-              <a:t>相关模块</a:t>
+              <a:t>相关代码</a:t>
             </a:r>
           </a:p>
         </p:txBody>
@@ -16200,7 +16200,7 @@
                 </a:solidFill>
                 <a:latin typeface="Arial"/>
               </a:rPr>
-              <a:t>关键结论</a:t>
+              <a:t>调研结论</a:t>
             </a:r>
           </a:p>
         </p:txBody>
@@ -16867,7 +16867,7 @@
                 </a:solidFill>
                 <a:latin typeface="Arial"/>
               </a:rPr>
-              <a:t>实现逻辑</a:t>
+              <a:t>实现含义</a:t>
             </a:r>
           </a:p>
         </p:txBody>
@@ -17003,7 +17003,7 @@
                 </a:solidFill>
                 <a:latin typeface="Arial"/>
               </a:rPr>
-              <a:t>相关模块</a:t>
+              <a:t>相关代码</a:t>
             </a:r>
           </a:p>
         </p:txBody>
@@ -17139,7 +17139,7 @@
                 </a:solidFill>
                 <a:latin typeface="Arial"/>
               </a:rPr>
-              <a:t>关键结论</a:t>
+              <a:t>调研结论</a:t>
             </a:r>
           </a:p>
         </p:txBody>
@@ -18212,7 +18212,7 @@
                 </a:solidFill>
                 <a:latin typeface="Arial"/>
               </a:rPr>
-              <a:t>关键结论</a:t>
+              <a:t>调研结论</a:t>
             </a:r>
           </a:p>
         </p:txBody>
@@ -19320,7 +19320,7 @@
                 </a:solidFill>
                 <a:latin typeface="Arial"/>
               </a:rPr>
-              <a:t>关键结论</a:t>
+              <a:t>调研结论</a:t>
             </a:r>
           </a:p>
         </p:txBody>
@@ -20427,7 +20427,7 @@
                 </a:solidFill>
                 <a:latin typeface="Arial"/>
               </a:rPr>
-              <a:t>关键结论</a:t>
+              <a:t>调研结论</a:t>
             </a:r>
           </a:p>
         </p:txBody>
@@ -21528,7 +21528,7 @@
                 </a:solidFill>
                 <a:latin typeface="Arial"/>
               </a:rPr>
-              <a:t>关键结论</a:t>
+              <a:t>调研结论</a:t>
             </a:r>
           </a:p>
         </p:txBody>
@@ -22387,7 +22387,7 @@
                 </a:solidFill>
                 <a:latin typeface="Arial"/>
               </a:rPr>
-              <a:t>实现逻辑</a:t>
+              <a:t>实现含义</a:t>
             </a:r>
           </a:p>
         </p:txBody>
@@ -22523,7 +22523,7 @@
                 </a:solidFill>
                 <a:latin typeface="Arial"/>
               </a:rPr>
-              <a:t>相关模块</a:t>
+              <a:t>相关代码</a:t>
             </a:r>
           </a:p>
         </p:txBody>
@@ -22675,7 +22675,7 @@
                 </a:solidFill>
                 <a:latin typeface="Arial"/>
               </a:rPr>
-              <a:t>关键结论</a:t>
+              <a:t>调研结论</a:t>
             </a:r>
           </a:p>
         </p:txBody>
@@ -23778,7 +23778,7 @@
                 </a:solidFill>
                 <a:latin typeface="Arial"/>
               </a:rPr>
-              <a:t>关键结论</a:t>
+              <a:t>调研结论</a:t>
             </a:r>
           </a:p>
         </p:txBody>
@@ -24882,7 +24882,7 @@
                 </a:solidFill>
                 <a:latin typeface="Arial"/>
               </a:rPr>
-              <a:t>关键结论</a:t>
+              <a:t>调研结论</a:t>
             </a:r>
           </a:p>
         </p:txBody>
@@ -25517,7 +25517,7 @@
                 </a:solidFill>
                 <a:latin typeface="Arial"/>
               </a:rPr>
-              <a:t>实现逻辑</a:t>
+              <a:t>实现含义</a:t>
             </a:r>
           </a:p>
         </p:txBody>
@@ -25653,7 +25653,7 @@
                 </a:solidFill>
                 <a:latin typeface="Arial"/>
               </a:rPr>
-              <a:t>相关模块</a:t>
+              <a:t>相关代码</a:t>
             </a:r>
           </a:p>
         </p:txBody>
@@ -25837,7 +25837,7 @@
                 </a:solidFill>
                 <a:latin typeface="Arial"/>
               </a:rPr>
-              <a:t>关键结论</a:t>
+              <a:t>调研结论</a:t>
             </a:r>
           </a:p>
         </p:txBody>
@@ -26696,7 +26696,7 @@
                 </a:solidFill>
                 <a:latin typeface="Arial"/>
               </a:rPr>
-              <a:t>实现逻辑</a:t>
+              <a:t>实现含义</a:t>
             </a:r>
           </a:p>
         </p:txBody>
@@ -26832,7 +26832,7 @@
                 </a:solidFill>
                 <a:latin typeface="Arial"/>
               </a:rPr>
-              <a:t>相关模块</a:t>
+              <a:t>相关代码</a:t>
             </a:r>
           </a:p>
         </p:txBody>
@@ -26984,7 +26984,7 @@
                 </a:solidFill>
                 <a:latin typeface="Arial"/>
               </a:rPr>
-              <a:t>关键结论</a:t>
+              <a:t>调研结论</a:t>
             </a:r>
           </a:p>
         </p:txBody>
@@ -27843,7 +27843,7 @@
                 </a:solidFill>
                 <a:latin typeface="Arial"/>
               </a:rPr>
-              <a:t>实现逻辑</a:t>
+              <a:t>实现含义</a:t>
             </a:r>
           </a:p>
         </p:txBody>
@@ -27979,7 +27979,7 @@
                 </a:solidFill>
                 <a:latin typeface="Arial"/>
               </a:rPr>
-              <a:t>相关模块</a:t>
+              <a:t>相关代码</a:t>
             </a:r>
           </a:p>
         </p:txBody>
@@ -28115,7 +28115,7 @@
                 </a:solidFill>
                 <a:latin typeface="Arial"/>
               </a:rPr>
-              <a:t>关键结论</a:t>
+              <a:t>调研结论</a:t>
             </a:r>
           </a:p>
         </p:txBody>
@@ -28974,7 +28974,7 @@
                 </a:solidFill>
                 <a:latin typeface="Arial"/>
               </a:rPr>
-              <a:t>实现逻辑</a:t>
+              <a:t>实现含义</a:t>
             </a:r>
           </a:p>
         </p:txBody>
@@ -29110,7 +29110,7 @@
                 </a:solidFill>
                 <a:latin typeface="Arial"/>
               </a:rPr>
-              <a:t>相关模块</a:t>
+              <a:t>相关代码</a:t>
             </a:r>
           </a:p>
         </p:txBody>
@@ -29262,7 +29262,7 @@
                 </a:solidFill>
                 <a:latin typeface="Arial"/>
               </a:rPr>
-              <a:t>关键结论</a:t>
+              <a:t>调研结论</a:t>
             </a:r>
           </a:p>
         </p:txBody>
@@ -30121,7 +30121,7 @@
                 </a:solidFill>
                 <a:latin typeface="Arial"/>
               </a:rPr>
-              <a:t>实现逻辑</a:t>
+              <a:t>实现含义</a:t>
             </a:r>
           </a:p>
         </p:txBody>
@@ -30257,7 +30257,7 @@
                 </a:solidFill>
                 <a:latin typeface="Arial"/>
               </a:rPr>
-              <a:t>相关模块</a:t>
+              <a:t>相关代码</a:t>
             </a:r>
           </a:p>
         </p:txBody>
@@ -30425,7 +30425,7 @@
                 </a:solidFill>
                 <a:latin typeface="Arial"/>
               </a:rPr>
-              <a:t>关键结论</a:t>
+              <a:t>调研结论</a:t>
             </a:r>
           </a:p>
         </p:txBody>
@@ -31268,7 +31268,7 @@
                 </a:solidFill>
                 <a:latin typeface="Arial"/>
               </a:rPr>
-              <a:t>实现逻辑</a:t>
+              <a:t>实现含义</a:t>
             </a:r>
           </a:p>
         </p:txBody>
@@ -31404,7 +31404,7 @@
                 </a:solidFill>
                 <a:latin typeface="Arial"/>
               </a:rPr>
-              <a:t>相关模块</a:t>
+              <a:t>相关代码</a:t>
             </a:r>
           </a:p>
         </p:txBody>
@@ -31556,7 +31556,7 @@
                 </a:solidFill>
                 <a:latin typeface="Arial"/>
               </a:rPr>
-              <a:t>关键结论</a:t>
+              <a:t>调研结论</a:t>
             </a:r>
           </a:p>
         </p:txBody>
@@ -32207,7 +32207,7 @@
                 </a:solidFill>
                 <a:latin typeface="Arial"/>
               </a:rPr>
-              <a:t>实现逻辑</a:t>
+              <a:t>实现含义</a:t>
             </a:r>
           </a:p>
         </p:txBody>
@@ -32343,7 +32343,7 @@
                 </a:solidFill>
                 <a:latin typeface="Arial"/>
               </a:rPr>
-              <a:t>相关模块</a:t>
+              <a:t>相关代码</a:t>
             </a:r>
           </a:p>
         </p:txBody>
@@ -32479,7 +32479,7 @@
                 </a:solidFill>
                 <a:latin typeface="Arial"/>
               </a:rPr>
-              <a:t>关键结论</a:t>
+              <a:t>调研结论</a:t>
             </a:r>
           </a:p>
         </p:txBody>
@@ -33134,7 +33134,7 @@
                 </a:solidFill>
                 <a:latin typeface="Arial"/>
               </a:rPr>
-              <a:t>实现逻辑</a:t>
+              <a:t>实现含义</a:t>
             </a:r>
           </a:p>
         </p:txBody>
@@ -33270,7 +33270,7 @@
                 </a:solidFill>
                 <a:latin typeface="Arial"/>
               </a:rPr>
-              <a:t>相关模块</a:t>
+              <a:t>相关代码</a:t>
             </a:r>
           </a:p>
         </p:txBody>
@@ -33406,7 +33406,7 @@
                 </a:solidFill>
                 <a:latin typeface="Arial"/>
               </a:rPr>
-              <a:t>关键结论</a:t>
+              <a:t>调研结论</a:t>
             </a:r>
           </a:p>
         </p:txBody>
@@ -34013,7 +34013,7 @@
                 </a:solidFill>
                 <a:latin typeface="Arial"/>
               </a:rPr>
-              <a:t>实现逻辑</a:t>
+              <a:t>实现含义</a:t>
             </a:r>
           </a:p>
         </p:txBody>
@@ -34149,7 +34149,7 @@
                 </a:solidFill>
                 <a:latin typeface="Arial"/>
               </a:rPr>
-              <a:t>相关模块</a:t>
+              <a:t>相关代码</a:t>
             </a:r>
           </a:p>
         </p:txBody>
@@ -34285,7 +34285,7 @@
                 </a:solidFill>
                 <a:latin typeface="Arial"/>
               </a:rPr>
-              <a:t>关键结论</a:t>
+              <a:t>调研结论</a:t>
             </a:r>
           </a:p>
         </p:txBody>
@@ -34892,7 +34892,7 @@
                 </a:solidFill>
                 <a:latin typeface="Arial"/>
               </a:rPr>
-              <a:t>实现逻辑</a:t>
+              <a:t>实现含义</a:t>
             </a:r>
           </a:p>
         </p:txBody>
@@ -35028,7 +35028,7 @@
                 </a:solidFill>
                 <a:latin typeface="Arial"/>
               </a:rPr>
-              <a:t>相关模块</a:t>
+              <a:t>相关代码</a:t>
             </a:r>
           </a:p>
         </p:txBody>
@@ -35164,7 +35164,7 @@
                 </a:solidFill>
                 <a:latin typeface="Arial"/>
               </a:rPr>
-              <a:t>关键结论</a:t>
+              <a:t>调研结论</a:t>
             </a:r>
           </a:p>
         </p:txBody>
@@ -35755,7 +35755,7 @@
                 </a:solidFill>
                 <a:latin typeface="Arial"/>
               </a:rPr>
-              <a:t>实现逻辑</a:t>
+              <a:t>实现含义</a:t>
             </a:r>
           </a:p>
         </p:txBody>
@@ -35891,7 +35891,7 @@
                 </a:solidFill>
                 <a:latin typeface="Arial"/>
               </a:rPr>
-              <a:t>相关模块</a:t>
+              <a:t>相关代码</a:t>
             </a:r>
           </a:p>
         </p:txBody>
@@ -36075,7 +36075,7 @@
                 </a:solidFill>
                 <a:latin typeface="Arial"/>
               </a:rPr>
-              <a:t>关键结论</a:t>
+              <a:t>调研结论</a:t>
             </a:r>
           </a:p>
         </p:txBody>
@@ -37198,7 +37198,7 @@
                 </a:solidFill>
                 <a:latin typeface="Arial"/>
               </a:rPr>
-              <a:t>关键结论</a:t>
+              <a:t>调研结论</a:t>
             </a:r>
           </a:p>
         </p:txBody>
@@ -37833,7 +37833,7 @@
                 </a:solidFill>
                 <a:latin typeface="Arial"/>
               </a:rPr>
-              <a:t>实现逻辑</a:t>
+              <a:t>实现含义</a:t>
             </a:r>
           </a:p>
         </p:txBody>
@@ -37872,7 +37872,7 @@
                 </a:solidFill>
                 <a:latin typeface="Arial"/>
               </a:rPr>
-              <a:t>这页主要是概览，不强行上代码块。</a:t>
+              <a:t>本页重点在于建立整体理解，而不是展开单段代码。</a:t>
             </a:r>
           </a:p>
         </p:txBody>
@@ -37969,7 +37969,7 @@
                 </a:solidFill>
                 <a:latin typeface="Arial"/>
               </a:rPr>
-              <a:t>相关模块</a:t>
+              <a:t>相关代码</a:t>
             </a:r>
           </a:p>
         </p:txBody>
@@ -38105,7 +38105,7 @@
                 </a:solidFill>
                 <a:latin typeface="Arial"/>
               </a:rPr>
-              <a:t>关键结论</a:t>
+              <a:t>调研结论</a:t>
             </a:r>
           </a:p>
         </p:txBody>
@@ -38664,7 +38664,7 @@
                 </a:solidFill>
                 <a:latin typeface="Arial"/>
               </a:rPr>
-              <a:t>实现逻辑</a:t>
+              <a:t>实现含义</a:t>
             </a:r>
           </a:p>
         </p:txBody>
@@ -38703,7 +38703,7 @@
                 </a:solidFill>
                 <a:latin typeface="Arial"/>
               </a:rPr>
-              <a:t>这页主要是概览，不强行上代码块。</a:t>
+              <a:t>本页重点在于建立整体理解，而不是展开单段代码。</a:t>
             </a:r>
           </a:p>
         </p:txBody>
@@ -38800,7 +38800,7 @@
                 </a:solidFill>
                 <a:latin typeface="Arial"/>
               </a:rPr>
-              <a:t>相关模块</a:t>
+              <a:t>相关代码</a:t>
             </a:r>
           </a:p>
         </p:txBody>
@@ -38936,7 +38936,7 @@
                 </a:solidFill>
                 <a:latin typeface="Arial"/>
               </a:rPr>
-              <a:t>关键结论</a:t>
+              <a:t>调研结论</a:t>
             </a:r>
           </a:p>
         </p:txBody>
@@ -39737,7 +39737,7 @@
                 </a:solidFill>
                 <a:latin typeface="Arial"/>
               </a:rPr>
-              <a:t>关键结论</a:t>
+              <a:t>调研结论</a:t>
             </a:r>
           </a:p>
         </p:txBody>
@@ -40538,7 +40538,7 @@
                 </a:solidFill>
                 <a:latin typeface="Arial"/>
               </a:rPr>
-              <a:t>关键结论</a:t>
+              <a:t>调研结论</a:t>
             </a:r>
           </a:p>
         </p:txBody>
@@ -41355,7 +41355,7 @@
                 </a:solidFill>
                 <a:latin typeface="Arial"/>
               </a:rPr>
-              <a:t>关键结论</a:t>
+              <a:t>调研结论</a:t>
             </a:r>
           </a:p>
         </p:txBody>
@@ -42156,7 +42156,7 @@
                 </a:solidFill>
                 <a:latin typeface="Arial"/>
               </a:rPr>
-              <a:t>关键结论</a:t>
+              <a:t>调研结论</a:t>
             </a:r>
           </a:p>
         </p:txBody>
@@ -42957,7 +42957,7 @@
                 </a:solidFill>
                 <a:latin typeface="Arial"/>
               </a:rPr>
-              <a:t>关键结论</a:t>
+              <a:t>调研结论</a:t>
             </a:r>
           </a:p>
         </p:txBody>
@@ -43758,7 +43758,7 @@
                 </a:solidFill>
                 <a:latin typeface="Arial"/>
               </a:rPr>
-              <a:t>关键结论</a:t>
+              <a:t>调研结论</a:t>
             </a:r>
           </a:p>
         </p:txBody>
@@ -44317,7 +44317,7 @@
                 </a:solidFill>
                 <a:latin typeface="Arial"/>
               </a:rPr>
-              <a:t>实现逻辑</a:t>
+              <a:t>实现含义</a:t>
             </a:r>
           </a:p>
         </p:txBody>
@@ -44453,7 +44453,7 @@
                 </a:solidFill>
                 <a:latin typeface="Arial"/>
               </a:rPr>
-              <a:t>相关模块</a:t>
+              <a:t>相关代码</a:t>
             </a:r>
           </a:p>
         </p:txBody>
@@ -44589,7 +44589,7 @@
                 </a:solidFill>
                 <a:latin typeface="Arial"/>
               </a:rPr>
-              <a:t>关键结论</a:t>
+              <a:t>调研结论</a:t>
             </a:r>
           </a:p>
         </p:txBody>
@@ -45160,7 +45160,7 @@
                 </a:solidFill>
                 <a:latin typeface="Arial"/>
               </a:rPr>
-              <a:t>实现逻辑</a:t>
+              <a:t>实现含义</a:t>
             </a:r>
           </a:p>
         </p:txBody>
@@ -45296,7 +45296,7 @@
                 </a:solidFill>
                 <a:latin typeface="Arial"/>
               </a:rPr>
-              <a:t>相关模块</a:t>
+              <a:t>相关代码</a:t>
             </a:r>
           </a:p>
         </p:txBody>
@@ -45448,7 +45448,7 @@
                 </a:solidFill>
                 <a:latin typeface="Arial"/>
               </a:rPr>
-              <a:t>关键结论</a:t>
+              <a:t>调研结论</a:t>
             </a:r>
           </a:p>
         </p:txBody>
@@ -46067,7 +46067,7 @@
                 </a:solidFill>
                 <a:latin typeface="Arial"/>
               </a:rPr>
-              <a:t>实现逻辑</a:t>
+              <a:t>实现含义</a:t>
             </a:r>
           </a:p>
         </p:txBody>
@@ -46203,7 +46203,7 @@
                 </a:solidFill>
                 <a:latin typeface="Arial"/>
               </a:rPr>
-              <a:t>相关模块</a:t>
+              <a:t>相关代码</a:t>
             </a:r>
           </a:p>
         </p:txBody>
@@ -46339,7 +46339,7 @@
                 </a:solidFill>
                 <a:latin typeface="Arial"/>
               </a:rPr>
-              <a:t>关键结论</a:t>
+              <a:t>调研结论</a:t>
             </a:r>
           </a:p>
         </p:txBody>
@@ -46930,7 +46930,7 @@
                 </a:solidFill>
                 <a:latin typeface="Arial"/>
               </a:rPr>
-              <a:t>实现逻辑</a:t>
+              <a:t>实现含义</a:t>
             </a:r>
           </a:p>
         </p:txBody>
@@ -47066,7 +47066,7 @@
                 </a:solidFill>
                 <a:latin typeface="Arial"/>
               </a:rPr>
-              <a:t>相关模块</a:t>
+              <a:t>相关代码</a:t>
             </a:r>
           </a:p>
         </p:txBody>
@@ -47202,7 +47202,7 @@
                 </a:solidFill>
                 <a:latin typeface="Arial"/>
               </a:rPr>
-              <a:t>关键结论</a:t>
+              <a:t>调研结论</a:t>
             </a:r>
           </a:p>
         </p:txBody>
@@ -47793,7 +47793,7 @@
                 </a:solidFill>
                 <a:latin typeface="Arial"/>
               </a:rPr>
-              <a:t>实现逻辑</a:t>
+              <a:t>实现含义</a:t>
             </a:r>
           </a:p>
         </p:txBody>
@@ -47929,7 +47929,7 @@
                 </a:solidFill>
                 <a:latin typeface="Arial"/>
               </a:rPr>
-              <a:t>相关模块</a:t>
+              <a:t>相关代码</a:t>
             </a:r>
           </a:p>
         </p:txBody>
@@ -48065,7 +48065,7 @@
                 </a:solidFill>
                 <a:latin typeface="Arial"/>
               </a:rPr>
-              <a:t>关键结论</a:t>
+              <a:t>调研结论</a:t>
             </a:r>
           </a:p>
         </p:txBody>
@@ -48656,7 +48656,7 @@
                 </a:solidFill>
                 <a:latin typeface="Arial"/>
               </a:rPr>
-              <a:t>实现逻辑</a:t>
+              <a:t>实现含义</a:t>
             </a:r>
           </a:p>
         </p:txBody>
@@ -48792,7 +48792,7 @@
                 </a:solidFill>
                 <a:latin typeface="Arial"/>
               </a:rPr>
-              <a:t>相关模块</a:t>
+              <a:t>相关代码</a:t>
             </a:r>
           </a:p>
         </p:txBody>
@@ -48928,7 +48928,7 @@
                 </a:solidFill>
                 <a:latin typeface="Arial"/>
               </a:rPr>
-              <a:t>关键结论</a:t>
+              <a:t>调研结论</a:t>
             </a:r>
           </a:p>
         </p:txBody>
@@ -49503,7 +49503,7 @@
                 </a:solidFill>
                 <a:latin typeface="Arial"/>
               </a:rPr>
-              <a:t>实现逻辑</a:t>
+              <a:t>实现含义</a:t>
             </a:r>
           </a:p>
         </p:txBody>
@@ -49542,7 +49542,7 @@
                 </a:solidFill>
                 <a:latin typeface="Arial"/>
               </a:rPr>
-              <a:t>这页主要是概览，不强行上代码块。</a:t>
+              <a:t>本页重点在于建立整体理解，而不是展开单段代码。</a:t>
             </a:r>
           </a:p>
         </p:txBody>
@@ -49639,7 +49639,7 @@
                 </a:solidFill>
                 <a:latin typeface="Arial"/>
               </a:rPr>
-              <a:t>相关模块</a:t>
+              <a:t>相关代码</a:t>
             </a:r>
           </a:p>
         </p:txBody>
@@ -49775,7 +49775,7 @@
                 </a:solidFill>
                 <a:latin typeface="Arial"/>
               </a:rPr>
-              <a:t>关键结论</a:t>
+              <a:t>调研结论</a:t>
             </a:r>
           </a:p>
         </p:txBody>
@@ -50382,7 +50382,7 @@
                 </a:solidFill>
                 <a:latin typeface="Arial"/>
               </a:rPr>
-              <a:t>实现逻辑</a:t>
+              <a:t>实现含义</a:t>
             </a:r>
           </a:p>
         </p:txBody>
@@ -50518,7 +50518,7 @@
                 </a:solidFill>
                 <a:latin typeface="Arial"/>
               </a:rPr>
-              <a:t>相关模块</a:t>
+              <a:t>相关代码</a:t>
             </a:r>
           </a:p>
         </p:txBody>
@@ -50654,7 +50654,7 @@
                 </a:solidFill>
                 <a:latin typeface="Arial"/>
               </a:rPr>
-              <a:t>关键结论</a:t>
+              <a:t>调研结论</a:t>
             </a:r>
           </a:p>
         </p:txBody>
@@ -51277,7 +51277,7 @@
                 </a:solidFill>
                 <a:latin typeface="Arial"/>
               </a:rPr>
-              <a:t>实现逻辑</a:t>
+              <a:t>实现含义</a:t>
             </a:r>
           </a:p>
         </p:txBody>
@@ -51413,7 +51413,7 @@
                 </a:solidFill>
                 <a:latin typeface="Arial"/>
               </a:rPr>
-              <a:t>相关模块</a:t>
+              <a:t>相关代码</a:t>
             </a:r>
           </a:p>
         </p:txBody>
@@ -51549,7 +51549,7 @@
                 </a:solidFill>
                 <a:latin typeface="Arial"/>
               </a:rPr>
-              <a:t>关键结论</a:t>
+              <a:t>调研结论</a:t>
             </a:r>
           </a:p>
         </p:txBody>
@@ -52204,7 +52204,7 @@
                 </a:solidFill>
                 <a:latin typeface="Arial"/>
               </a:rPr>
-              <a:t>实现逻辑</a:t>
+              <a:t>实现含义</a:t>
             </a:r>
           </a:p>
         </p:txBody>
@@ -52340,7 +52340,7 @@
                 </a:solidFill>
                 <a:latin typeface="Arial"/>
               </a:rPr>
-              <a:t>相关模块</a:t>
+              <a:t>相关代码</a:t>
             </a:r>
           </a:p>
         </p:txBody>
@@ -52476,7 +52476,7 @@
                 </a:solidFill>
                 <a:latin typeface="Arial"/>
               </a:rPr>
-              <a:t>关键结论</a:t>
+              <a:t>调研结论</a:t>
             </a:r>
           </a:p>
         </p:txBody>
@@ -53281,7 +53281,7 @@
                 </a:solidFill>
                 <a:latin typeface="Arial"/>
               </a:rPr>
-              <a:t>关键结论</a:t>
+              <a:t>调研结论</a:t>
             </a:r>
           </a:p>
         </p:txBody>
@@ -53888,7 +53888,7 @@
                 </a:solidFill>
                 <a:latin typeface="Arial"/>
               </a:rPr>
-              <a:t>实现逻辑</a:t>
+              <a:t>实现含义</a:t>
             </a:r>
           </a:p>
         </p:txBody>
@@ -54024,7 +54024,7 @@
                 </a:solidFill>
                 <a:latin typeface="Arial"/>
               </a:rPr>
-              <a:t>相关模块</a:t>
+              <a:t>相关代码</a:t>
             </a:r>
           </a:p>
         </p:txBody>
@@ -54208,7 +54208,7 @@
                 </a:solidFill>
                 <a:latin typeface="Arial"/>
               </a:rPr>
-              <a:t>关键结论</a:t>
+              <a:t>调研结论</a:t>
             </a:r>
           </a:p>
         </p:txBody>
@@ -54811,7 +54811,7 @@
                 </a:solidFill>
                 <a:latin typeface="Arial"/>
               </a:rPr>
-              <a:t>实现逻辑</a:t>
+              <a:t>实现含义</a:t>
             </a:r>
           </a:p>
         </p:txBody>
@@ -54850,7 +54850,7 @@
                 </a:solidFill>
                 <a:latin typeface="Arial"/>
               </a:rPr>
-              <a:t>这页主要是概览，不强行上代码块。</a:t>
+              <a:t>本页重点在于建立整体理解，而不是展开单段代码。</a:t>
             </a:r>
           </a:p>
         </p:txBody>
@@ -54947,7 +54947,7 @@
                 </a:solidFill>
                 <a:latin typeface="Arial"/>
               </a:rPr>
-              <a:t>相关模块</a:t>
+              <a:t>相关代码</a:t>
             </a:r>
           </a:p>
         </p:txBody>
@@ -55083,7 +55083,7 @@
                 </a:solidFill>
                 <a:latin typeface="Arial"/>
               </a:rPr>
-              <a:t>关键结论</a:t>
+              <a:t>调研结论</a:t>
             </a:r>
           </a:p>
         </p:txBody>
@@ -55658,7 +55658,7 @@
                 </a:solidFill>
                 <a:latin typeface="Arial"/>
               </a:rPr>
-              <a:t>实现逻辑</a:t>
+              <a:t>实现含义</a:t>
             </a:r>
           </a:p>
         </p:txBody>
@@ -55794,7 +55794,7 @@
                 </a:solidFill>
                 <a:latin typeface="Arial"/>
               </a:rPr>
-              <a:t>相关模块</a:t>
+              <a:t>相关代码</a:t>
             </a:r>
           </a:p>
         </p:txBody>
@@ -55930,7 +55930,7 @@
                 </a:solidFill>
                 <a:latin typeface="Arial"/>
               </a:rPr>
-              <a:t>关键结论</a:t>
+              <a:t>调研结论</a:t>
             </a:r>
           </a:p>
         </p:txBody>

</xml_diff>

<commit_message>
Add speaker notes for recovery and content replacement
</commit_message>
<xml_diff>
--- a/docs/zh/10-Claude Code 源码调研.pptx
+++ b/docs/zh/10-Claude Code 源码调研.pptx
@@ -16,35 +16,35 @@
     <p:sldId id="264" r:id="rId15"/>
     <p:sldId id="265" r:id="rId16"/>
     <p:sldId id="266" r:id="rId17"/>
-    <p:sldId id="267" r:id="rId18"/>
-    <p:sldId id="268" r:id="rId19"/>
-    <p:sldId id="269" r:id="rId20"/>
-    <p:sldId id="270" r:id="rId21"/>
-    <p:sldId id="271" r:id="rId22"/>
-    <p:sldId id="272" r:id="rId23"/>
-    <p:sldId id="273" r:id="rId24"/>
-    <p:sldId id="274" r:id="rId25"/>
-    <p:sldId id="275" r:id="rId26"/>
-    <p:sldId id="276" r:id="rId27"/>
-    <p:sldId id="277" r:id="rId28"/>
-    <p:sldId id="278" r:id="rId29"/>
-    <p:sldId id="279" r:id="rId30"/>
-    <p:sldId id="280" r:id="rId31"/>
-    <p:sldId id="281" r:id="rId32"/>
-    <p:sldId id="282" r:id="rId33"/>
-    <p:sldId id="283" r:id="rId34"/>
-    <p:sldId id="284" r:id="rId35"/>
-    <p:sldId id="285" r:id="rId36"/>
-    <p:sldId id="286" r:id="rId37"/>
-    <p:sldId id="287" r:id="rId38"/>
-    <p:sldId id="288" r:id="rId39"/>
-    <p:sldId id="289" r:id="rId40"/>
-    <p:sldId id="290" r:id="rId41"/>
-    <p:sldId id="291" r:id="rId42"/>
-    <p:sldId id="292" r:id="rId43"/>
-    <p:sldId id="293" r:id="rId44"/>
-    <p:sldId id="294" r:id="rId45"/>
-    <p:sldId id="295" r:id="rId46"/>
+    <p:sldId id="267" r:id="rId19"/>
+    <p:sldId id="268" r:id="rId20"/>
+    <p:sldId id="269" r:id="rId21"/>
+    <p:sldId id="270" r:id="rId22"/>
+    <p:sldId id="271" r:id="rId23"/>
+    <p:sldId id="272" r:id="rId24"/>
+    <p:sldId id="273" r:id="rId25"/>
+    <p:sldId id="274" r:id="rId26"/>
+    <p:sldId id="275" r:id="rId27"/>
+    <p:sldId id="276" r:id="rId28"/>
+    <p:sldId id="277" r:id="rId29"/>
+    <p:sldId id="278" r:id="rId30"/>
+    <p:sldId id="279" r:id="rId31"/>
+    <p:sldId id="280" r:id="rId32"/>
+    <p:sldId id="281" r:id="rId33"/>
+    <p:sldId id="282" r:id="rId34"/>
+    <p:sldId id="283" r:id="rId35"/>
+    <p:sldId id="284" r:id="rId36"/>
+    <p:sldId id="285" r:id="rId37"/>
+    <p:sldId id="286" r:id="rId38"/>
+    <p:sldId id="287" r:id="rId39"/>
+    <p:sldId id="288" r:id="rId40"/>
+    <p:sldId id="289" r:id="rId41"/>
+    <p:sldId id="290" r:id="rId42"/>
+    <p:sldId id="291" r:id="rId43"/>
+    <p:sldId id="292" r:id="rId44"/>
+    <p:sldId id="293" r:id="rId45"/>
+    <p:sldId id="294" r:id="rId46"/>
+    <p:sldId id="295" r:id="rId47"/>
   </p:sldIdLst>
   <p:sldSz cx="12191695" cy="6858000" type="screen4x3"/>
   <p:notesSz cx="6858000" cy="9144000"/>
@@ -144,6 +144,577 @@
     </a:lvl9pPr>
   </p:defaultTextStyle>
 </p:presentation>
+</file>
+
+<file path=ppt/notesMasters/notesMaster1.xml><?xml version="1.0" encoding="utf-8"?>
+<p:notesMaster xmlns:a="http://schemas.openxmlformats.org/drawingml/2006/main" xmlns:p="http://schemas.openxmlformats.org/presentationml/2006/main" xmlns:r="http://schemas.openxmlformats.org/officeDocument/2006/relationships">
+  <p:cSld>
+    <p:bg>
+      <p:bgRef idx="1001">
+        <a:schemeClr val="bg1"/>
+      </p:bgRef>
+    </p:bg>
+    <p:spTree>
+      <p:nvGrpSpPr>
+        <p:cNvPr id="1" name=""/>
+        <p:cNvGrpSpPr/>
+        <p:nvPr/>
+      </p:nvGrpSpPr>
+      <p:grpSpPr>
+        <a:xfrm>
+          <a:off x="0" y="0"/>
+          <a:ext cx="0" cy="0"/>
+          <a:chOff x="0" y="0"/>
+          <a:chExt cx="0" cy="0"/>
+        </a:xfrm>
+      </p:grpSpPr>
+      <p:sp>
+        <p:nvSpPr>
+          <p:cNvPr id="2" name="Header Placeholder 1"/>
+          <p:cNvSpPr>
+            <a:spLocks noGrp="1"/>
+          </p:cNvSpPr>
+          <p:nvPr>
+            <p:ph type="hdr" sz="quarter"/>
+          </p:nvPr>
+        </p:nvSpPr>
+        <p:spPr>
+          <a:xfrm>
+            <a:off x="0" y="0"/>
+            <a:ext cx="2971800" cy="457200"/>
+          </a:xfrm>
+          <a:prstGeom prst="rect">
+            <a:avLst/>
+          </a:prstGeom>
+        </p:spPr>
+        <p:txBody>
+          <a:bodyPr vert="horz" lIns="91440" tIns="45720" rIns="91440" bIns="45720" rtlCol="0"/>
+          <a:lstStyle>
+            <a:lvl1pPr algn="l">
+              <a:defRPr sz="1200"/>
+            </a:lvl1pPr>
+          </a:lstStyle>
+          <a:p>
+            <a:endParaRPr lang="en-US"/>
+          </a:p>
+        </p:txBody>
+      </p:sp>
+      <p:sp>
+        <p:nvSpPr>
+          <p:cNvPr id="3" name="Date Placeholder 2"/>
+          <p:cNvSpPr>
+            <a:spLocks noGrp="1"/>
+          </p:cNvSpPr>
+          <p:nvPr>
+            <p:ph type="dt" idx="1"/>
+          </p:nvPr>
+        </p:nvSpPr>
+        <p:spPr>
+          <a:xfrm>
+            <a:off x="3884613" y="0"/>
+            <a:ext cx="2971800" cy="457200"/>
+          </a:xfrm>
+          <a:prstGeom prst="rect">
+            <a:avLst/>
+          </a:prstGeom>
+        </p:spPr>
+        <p:txBody>
+          <a:bodyPr vert="horz" lIns="91440" tIns="45720" rIns="91440" bIns="45720" rtlCol="0"/>
+          <a:lstStyle>
+            <a:lvl1pPr algn="r">
+              <a:defRPr sz="1200"/>
+            </a:lvl1pPr>
+          </a:lstStyle>
+          <a:p>
+            <a:fld id="{0F89C1C7-3DCD-1040-A9CF-14679D8B5DDD}" type="datetimeFigureOut">
+              <a:rPr lang="en-US" smtClean="0"/>
+              <a:t>10/17/16</a:t>
+            </a:fld>
+            <a:endParaRPr lang="en-US"/>
+          </a:p>
+        </p:txBody>
+      </p:sp>
+      <p:sp>
+        <p:nvSpPr>
+          <p:cNvPr id="4" name="Slide Image Placeholder 3"/>
+          <p:cNvSpPr>
+            <a:spLocks noGrp="1" noRot="1" noChangeAspect="1"/>
+          </p:cNvSpPr>
+          <p:nvPr>
+            <p:ph type="sldImg" idx="2"/>
+          </p:nvPr>
+        </p:nvSpPr>
+        <p:spPr>
+          <a:xfrm>
+            <a:off x="1143000" y="685800"/>
+            <a:ext cx="4572000" cy="3429000"/>
+          </a:xfrm>
+          <a:prstGeom prst="rect">
+            <a:avLst/>
+          </a:prstGeom>
+          <a:noFill/>
+          <a:ln w="12700">
+            <a:solidFill>
+              <a:prstClr val="black"/>
+            </a:solidFill>
+          </a:ln>
+        </p:spPr>
+        <p:txBody>
+          <a:bodyPr vert="horz" lIns="91440" tIns="45720" rIns="91440" bIns="45720" rtlCol="0" anchor="ctr"/>
+          <a:lstStyle/>
+          <a:p>
+            <a:endParaRPr lang="en-US"/>
+          </a:p>
+        </p:txBody>
+      </p:sp>
+      <p:sp>
+        <p:nvSpPr>
+          <p:cNvPr id="5" name="Notes Placeholder 4"/>
+          <p:cNvSpPr>
+            <a:spLocks noGrp="1"/>
+          </p:cNvSpPr>
+          <p:nvPr>
+            <p:ph type="body" sz="quarter" idx="3"/>
+          </p:nvPr>
+        </p:nvSpPr>
+        <p:spPr>
+          <a:xfrm>
+            <a:off x="685800" y="4343400"/>
+            <a:ext cx="5486400" cy="4114800"/>
+          </a:xfrm>
+          <a:prstGeom prst="rect">
+            <a:avLst/>
+          </a:prstGeom>
+        </p:spPr>
+        <p:txBody>
+          <a:bodyPr vert="horz" lIns="91440" tIns="45720" rIns="91440" bIns="45720" rtlCol="0"/>
+          <a:lstStyle/>
+          <a:p>
+            <a:pPr lvl="0"/>
+            <a:r>
+              <a:rPr lang="en-US" smtClean="0"/>
+              <a:t>Click to edit Master text styles</a:t>
+            </a:r>
+          </a:p>
+          <a:p>
+            <a:pPr lvl="1"/>
+            <a:r>
+              <a:rPr lang="en-US" smtClean="0"/>
+              <a:t>Second level</a:t>
+            </a:r>
+          </a:p>
+          <a:p>
+            <a:pPr lvl="2"/>
+            <a:r>
+              <a:rPr lang="en-US" smtClean="0"/>
+              <a:t>Third level</a:t>
+            </a:r>
+          </a:p>
+          <a:p>
+            <a:pPr lvl="3"/>
+            <a:r>
+              <a:rPr lang="en-US" smtClean="0"/>
+              <a:t>Fourth level</a:t>
+            </a:r>
+          </a:p>
+          <a:p>
+            <a:pPr lvl="4"/>
+            <a:r>
+              <a:rPr lang="en-US" smtClean="0"/>
+              <a:t>Fifth level</a:t>
+            </a:r>
+            <a:endParaRPr lang="en-US"/>
+          </a:p>
+        </p:txBody>
+      </p:sp>
+      <p:sp>
+        <p:nvSpPr>
+          <p:cNvPr id="6" name="Footer Placeholder 5"/>
+          <p:cNvSpPr>
+            <a:spLocks noGrp="1"/>
+          </p:cNvSpPr>
+          <p:nvPr>
+            <p:ph type="ftr" sz="quarter" idx="4"/>
+          </p:nvPr>
+        </p:nvSpPr>
+        <p:spPr>
+          <a:xfrm>
+            <a:off x="0" y="8685213"/>
+            <a:ext cx="2971800" cy="457200"/>
+          </a:xfrm>
+          <a:prstGeom prst="rect">
+            <a:avLst/>
+          </a:prstGeom>
+        </p:spPr>
+        <p:txBody>
+          <a:bodyPr vert="horz" lIns="91440" tIns="45720" rIns="91440" bIns="45720" rtlCol="0" anchor="b"/>
+          <a:lstStyle>
+            <a:lvl1pPr algn="l">
+              <a:defRPr sz="1200"/>
+            </a:lvl1pPr>
+          </a:lstStyle>
+          <a:p>
+            <a:endParaRPr lang="en-US"/>
+          </a:p>
+        </p:txBody>
+      </p:sp>
+      <p:sp>
+        <p:nvSpPr>
+          <p:cNvPr id="7" name="Slide Number Placeholder 6"/>
+          <p:cNvSpPr>
+            <a:spLocks noGrp="1"/>
+          </p:cNvSpPr>
+          <p:nvPr>
+            <p:ph type="sldNum" sz="quarter" idx="5"/>
+          </p:nvPr>
+        </p:nvSpPr>
+        <p:spPr>
+          <a:xfrm>
+            <a:off x="3884613" y="8685213"/>
+            <a:ext cx="2971800" cy="457200"/>
+          </a:xfrm>
+          <a:prstGeom prst="rect">
+            <a:avLst/>
+          </a:prstGeom>
+        </p:spPr>
+        <p:txBody>
+          <a:bodyPr vert="horz" lIns="91440" tIns="45720" rIns="91440" bIns="45720" rtlCol="0" anchor="b"/>
+          <a:lstStyle>
+            <a:lvl1pPr algn="r">
+              <a:defRPr sz="1200"/>
+            </a:lvl1pPr>
+          </a:lstStyle>
+          <a:p>
+            <a:fld id="{BB5E49A5-4136-284D-997B-48E1D791AD67}" type="slidenum">
+              <a:rPr lang="en-US" smtClean="0"/>
+              <a:t>‹#›</a:t>
+            </a:fld>
+            <a:endParaRPr lang="en-US"/>
+          </a:p>
+        </p:txBody>
+      </p:sp>
+    </p:spTree>
+    <p:extLst>
+      <p:ext uri="{BB962C8B-B14F-4D97-AF65-F5344CB8AC3E}">
+        <p14:creationId xmlns:p14="http://schemas.microsoft.com/office/powerpoint/2010/main" val="2623252185"/>
+      </p:ext>
+    </p:extLst>
+  </p:cSld>
+  <p:clrMap bg1="lt1" tx1="dk1" bg2="lt2" tx2="dk2" accent1="accent1" accent2="accent2" accent3="accent3" accent4="accent4" accent5="accent5" accent6="accent6" hlink="hlink" folHlink="folHlink"/>
+  <p:notesStyle>
+    <a:lvl1pPr marL="0" algn="l" defTabSz="457200" rtl="0" eaLnBrk="1" latinLnBrk="0" hangingPunct="1">
+      <a:defRPr sz="1200" kern="1200">
+        <a:solidFill>
+          <a:schemeClr val="tx1"/>
+        </a:solidFill>
+        <a:latin typeface="+mn-lt"/>
+        <a:ea typeface="+mn-ea"/>
+        <a:cs typeface="+mn-cs"/>
+      </a:defRPr>
+    </a:lvl1pPr>
+    <a:lvl2pPr marL="457200" algn="l" defTabSz="457200" rtl="0" eaLnBrk="1" latinLnBrk="0" hangingPunct="1">
+      <a:defRPr sz="1200" kern="1200">
+        <a:solidFill>
+          <a:schemeClr val="tx1"/>
+        </a:solidFill>
+        <a:latin typeface="+mn-lt"/>
+        <a:ea typeface="+mn-ea"/>
+        <a:cs typeface="+mn-cs"/>
+      </a:defRPr>
+    </a:lvl2pPr>
+    <a:lvl3pPr marL="914400" algn="l" defTabSz="457200" rtl="0" eaLnBrk="1" latinLnBrk="0" hangingPunct="1">
+      <a:defRPr sz="1200" kern="1200">
+        <a:solidFill>
+          <a:schemeClr val="tx1"/>
+        </a:solidFill>
+        <a:latin typeface="+mn-lt"/>
+        <a:ea typeface="+mn-ea"/>
+        <a:cs typeface="+mn-cs"/>
+      </a:defRPr>
+    </a:lvl3pPr>
+    <a:lvl4pPr marL="1371600" algn="l" defTabSz="457200" rtl="0" eaLnBrk="1" latinLnBrk="0" hangingPunct="1">
+      <a:defRPr sz="1200" kern="1200">
+        <a:solidFill>
+          <a:schemeClr val="tx1"/>
+        </a:solidFill>
+        <a:latin typeface="+mn-lt"/>
+        <a:ea typeface="+mn-ea"/>
+        <a:cs typeface="+mn-cs"/>
+      </a:defRPr>
+    </a:lvl4pPr>
+    <a:lvl5pPr marL="1828800" algn="l" defTabSz="457200" rtl="0" eaLnBrk="1" latinLnBrk="0" hangingPunct="1">
+      <a:defRPr sz="1200" kern="1200">
+        <a:solidFill>
+          <a:schemeClr val="tx1"/>
+        </a:solidFill>
+        <a:latin typeface="+mn-lt"/>
+        <a:ea typeface="+mn-ea"/>
+        <a:cs typeface="+mn-cs"/>
+      </a:defRPr>
+    </a:lvl5pPr>
+    <a:lvl6pPr marL="2286000" algn="l" defTabSz="457200" rtl="0" eaLnBrk="1" latinLnBrk="0" hangingPunct="1">
+      <a:defRPr sz="1200" kern="1200">
+        <a:solidFill>
+          <a:schemeClr val="tx1"/>
+        </a:solidFill>
+        <a:latin typeface="+mn-lt"/>
+        <a:ea typeface="+mn-ea"/>
+        <a:cs typeface="+mn-cs"/>
+      </a:defRPr>
+    </a:lvl6pPr>
+    <a:lvl7pPr marL="2743200" algn="l" defTabSz="457200" rtl="0" eaLnBrk="1" latinLnBrk="0" hangingPunct="1">
+      <a:defRPr sz="1200" kern="1200">
+        <a:solidFill>
+          <a:schemeClr val="tx1"/>
+        </a:solidFill>
+        <a:latin typeface="+mn-lt"/>
+        <a:ea typeface="+mn-ea"/>
+        <a:cs typeface="+mn-cs"/>
+      </a:defRPr>
+    </a:lvl7pPr>
+    <a:lvl8pPr marL="3200400" algn="l" defTabSz="457200" rtl="0" eaLnBrk="1" latinLnBrk="0" hangingPunct="1">
+      <a:defRPr sz="1200" kern="1200">
+        <a:solidFill>
+          <a:schemeClr val="tx1"/>
+        </a:solidFill>
+        <a:latin typeface="+mn-lt"/>
+        <a:ea typeface="+mn-ea"/>
+        <a:cs typeface="+mn-cs"/>
+      </a:defRPr>
+    </a:lvl8pPr>
+    <a:lvl9pPr marL="3657600" algn="l" defTabSz="457200" rtl="0" eaLnBrk="1" latinLnBrk="0" hangingPunct="1">
+      <a:defRPr sz="1200" kern="1200">
+        <a:solidFill>
+          <a:schemeClr val="tx1"/>
+        </a:solidFill>
+        <a:latin typeface="+mn-lt"/>
+        <a:ea typeface="+mn-ea"/>
+        <a:cs typeface="+mn-cs"/>
+      </a:defRPr>
+    </a:lvl9pPr>
+  </p:notesStyle>
+</p:notesMaster>
+</file>
+
+<file path=ppt/notesSlides/notesSlide1.xml><?xml version="1.0" encoding="utf-8"?>
+<p:notes xmlns:a="http://schemas.openxmlformats.org/drawingml/2006/main" xmlns:p="http://schemas.openxmlformats.org/presentationml/2006/main" xmlns:r="http://schemas.openxmlformats.org/officeDocument/2006/relationships">
+  <p:cSld>
+    <p:spTree>
+      <p:nvGrpSpPr>
+        <p:cNvPr id="1" name=""/>
+        <p:cNvGrpSpPr/>
+        <p:nvPr/>
+      </p:nvGrpSpPr>
+      <p:grpSpPr>
+        <a:xfrm>
+          <a:off x="0" y="0"/>
+          <a:ext cx="0" cy="0"/>
+          <a:chOff x="0" y="0"/>
+          <a:chExt cx="0" cy="0"/>
+        </a:xfrm>
+      </p:grpSpPr>
+      <p:sp>
+        <p:nvSpPr>
+          <p:cNvPr id="2" name="Slide Image Placeholder 1"/>
+          <p:cNvSpPr>
+            <a:spLocks noGrp="1"/>
+          </p:cNvSpPr>
+          <p:nvPr>
+            <p:ph type="sldImg" idx="2"/>
+          </p:nvPr>
+        </p:nvSpPr>
+        <p:spPr/>
+      </p:sp>
+      <p:sp>
+        <p:nvSpPr>
+          <p:cNvPr id="3" name="Notes Placeholder 2"/>
+          <p:cNvSpPr>
+            <a:spLocks noGrp="1"/>
+          </p:cNvSpPr>
+          <p:nvPr>
+            <p:ph type="body" idx="3" sz="quarter"/>
+          </p:nvPr>
+        </p:nvSpPr>
+        <p:spPr/>
+        <p:txBody>
+          <a:bodyPr/>
+          <a:lstStyle/>
+          <a:p>
+            <a:r>
+              <a:t>补充说明：</a:t>
+            </a:r>
+          </a:p>
+          <a:p/>
+          <a:p>
+            <a:r>
+              <a:t>- resume 时不是直接反序列化，而是先把历史修回 API 可继续状态。</a:t>
+            </a:r>
+          </a:p>
+          <a:p>
+            <a:r>
+              <a:t>- 所以 recovery 的目标不是“还原 UI”，而是“恢复一个还能继续跑的 runtime”。</a:t>
+            </a:r>
+          </a:p>
+          <a:p>
+            <a:r>
+              <a:t>- 这也是为什么 conversationRecovery.ts 会先过滤 unresolved tool use、orphaned thinking、whitespace-only assistant messages，再把消息恢复成可继续调用 API 的形态。</a:t>
+            </a:r>
+          </a:p>
+          <a:p/>
+          <a:p>
+            <a:r>
+              <a:t>相关延伸材料：</a:t>
+            </a:r>
+          </a:p>
+          <a:p>
+            <a:r>
+              <a:t>- 06-走读附录：长会话与恢复机制.md</a:t>
+            </a:r>
+          </a:p>
+        </p:txBody>
+      </p:sp>
+      <p:sp>
+        <p:nvSpPr>
+          <p:cNvPr id="4" name="Slide Number Placeholder 3"/>
+          <p:cNvSpPr>
+            <a:spLocks noGrp="1"/>
+          </p:cNvSpPr>
+          <p:nvPr>
+            <p:ph type="sldNum" idx="5" sz="quarter"/>
+          </p:nvPr>
+        </p:nvSpPr>
+        <p:spPr/>
+      </p:sp>
+    </p:spTree>
+  </p:cSld>
+  <p:clrMapOvr>
+    <a:masterClrMapping/>
+  </p:clrMapOvr>
+</p:notes>
+</file>
+
+<file path=ppt/notesSlides/notesSlide2.xml><?xml version="1.0" encoding="utf-8"?>
+<p:notes xmlns:a="http://schemas.openxmlformats.org/drawingml/2006/main" xmlns:p="http://schemas.openxmlformats.org/presentationml/2006/main" xmlns:r="http://schemas.openxmlformats.org/officeDocument/2006/relationships">
+  <p:cSld>
+    <p:spTree>
+      <p:nvGrpSpPr>
+        <p:cNvPr id="1" name=""/>
+        <p:cNvGrpSpPr/>
+        <p:nvPr/>
+      </p:nvGrpSpPr>
+      <p:grpSpPr>
+        <a:xfrm>
+          <a:off x="0" y="0"/>
+          <a:ext cx="0" cy="0"/>
+          <a:chOff x="0" y="0"/>
+          <a:chExt cx="0" cy="0"/>
+        </a:xfrm>
+      </p:grpSpPr>
+      <p:sp>
+        <p:nvSpPr>
+          <p:cNvPr id="2" name="Slide Image Placeholder 1"/>
+          <p:cNvSpPr>
+            <a:spLocks noGrp="1"/>
+          </p:cNvSpPr>
+          <p:nvPr>
+            <p:ph type="sldImg" idx="2"/>
+          </p:nvPr>
+        </p:nvSpPr>
+        <p:spPr/>
+      </p:sp>
+      <p:sp>
+        <p:nvSpPr>
+          <p:cNvPr id="3" name="Notes Placeholder 2"/>
+          <p:cNvSpPr>
+            <a:spLocks noGrp="1"/>
+          </p:cNvSpPr>
+          <p:nvPr>
+            <p:ph type="body" idx="3" sz="quarter"/>
+          </p:nvPr>
+        </p:nvSpPr>
+        <p:spPr/>
+        <p:txBody>
+          <a:bodyPr/>
+          <a:lstStyle/>
+          <a:p>
+            <a:r>
+              <a:t>补充说明：</a:t>
+            </a:r>
+          </a:p>
+          <a:p/>
+          <a:p>
+            <a:r>
+              <a:t>4.2 tool result budget / content replacement 解决的是“冻结输出命运”。</a:t>
+            </a:r>
+          </a:p>
+          <a:p/>
+          <a:p>
+            <a:r>
+              <a:t>关键文件：</a:t>
+            </a:r>
+          </a:p>
+          <a:p>
+            <a:r>
+              <a:t>- src/utils/toolResultStorage.ts</a:t>
+            </a:r>
+          </a:p>
+          <a:p>
+            <a:r>
+              <a:t>- src/services/compact/microCompact.ts</a:t>
+            </a:r>
+          </a:p>
+          <a:p/>
+          <a:p>
+            <a:r>
+              <a:t>这一层解决的不是“截断输出”，而是：</a:t>
+            </a:r>
+          </a:p>
+          <a:p>
+            <a:r>
+              <a:t>- 大工具输出先落盘</a:t>
+            </a:r>
+          </a:p>
+          <a:p>
+            <a:r>
+              <a:t>- 上下文里只保留稳定 preview</a:t>
+            </a:r>
+          </a:p>
+          <a:p>
+            <a:r>
+              <a:t>- 某个 tool_use_id 一旦替换，后面始终使用同一 replacement string</a:t>
+            </a:r>
+          </a:p>
+          <a:p>
+            <a:r>
+              <a:t>- 恢复后还要重放同一 replacement，保护 prompt cache prefix</a:t>
+            </a:r>
+          </a:p>
+          <a:p/>
+          <a:p>
+            <a:r>
+              <a:t>这层非常值钱，因为它说明 Claude Code 在认真维护长会话的稳定性，而不是简单把大文本塞进上下文。</a:t>
+            </a:r>
+          </a:p>
+        </p:txBody>
+      </p:sp>
+      <p:sp>
+        <p:nvSpPr>
+          <p:cNvPr id="4" name="Slide Number Placeholder 3"/>
+          <p:cNvSpPr>
+            <a:spLocks noGrp="1"/>
+          </p:cNvSpPr>
+          <p:nvPr>
+            <p:ph type="sldNum" idx="5" sz="quarter"/>
+          </p:nvPr>
+        </p:nvSpPr>
+        <p:spPr/>
+      </p:sp>
+    </p:spTree>
+  </p:cSld>
+  <p:clrMapOvr>
+    <a:masterClrMapping/>
+  </p:clrMapOvr>
+</p:notes>
 </file>
 
 <file path=ppt/slideLayouts/slideLayout1.xml><?xml version="1.0" encoding="utf-8"?>
@@ -41908,4 +42479,324 @@
   </a:objectDefaults>
   <a:extraClrSchemeLst/>
 </a:theme>
+</file>
+
+<file path=ppt/theme/theme2.xml><?xml version="1.0" encoding="utf-8"?>
+<a:theme xmlns:a="http://schemas.openxmlformats.org/drawingml/2006/main" name="Office Theme">
+  <a:themeElements>
+    <a:clrScheme name="Office">
+      <a:dk1>
+        <a:sysClr val="windowText" lastClr="000000"/>
+      </a:dk1>
+      <a:lt1>
+        <a:sysClr val="window" lastClr="FFFFFF"/>
+      </a:lt1>
+      <a:dk2>
+        <a:srgbClr val="1F497D"/>
+      </a:dk2>
+      <a:lt2>
+        <a:srgbClr val="EEECE1"/>
+      </a:lt2>
+      <a:accent1>
+        <a:srgbClr val="4F81BD"/>
+      </a:accent1>
+      <a:accent2>
+        <a:srgbClr val="C0504D"/>
+      </a:accent2>
+      <a:accent3>
+        <a:srgbClr val="9BBB59"/>
+      </a:accent3>
+      <a:accent4>
+        <a:srgbClr val="8064A2"/>
+      </a:accent4>
+      <a:accent5>
+        <a:srgbClr val="4BACC6"/>
+      </a:accent5>
+      <a:accent6>
+        <a:srgbClr val="F79646"/>
+      </a:accent6>
+      <a:hlink>
+        <a:srgbClr val="0000FF"/>
+      </a:hlink>
+      <a:folHlink>
+        <a:srgbClr val="800080"/>
+      </a:folHlink>
+    </a:clrScheme>
+    <a:fontScheme name="Office">
+      <a:majorFont>
+        <a:latin typeface="Calibri"/>
+        <a:ea typeface=""/>
+        <a:cs typeface=""/>
+        <a:font script="Jpan" typeface="ＭＳ Ｐゴシック"/>
+        <a:font script="Hang" typeface="맑은 고딕"/>
+        <a:font script="Hans" typeface="宋体"/>
+        <a:font script="Hant" typeface="新細明體"/>
+        <a:font script="Arab" typeface="Times New Roman"/>
+        <a:font script="Hebr" typeface="Times New Roman"/>
+        <a:font script="Thai" typeface="Angsana New"/>
+        <a:font script="Ethi" typeface="Nyala"/>
+        <a:font script="Beng" typeface="Vrinda"/>
+        <a:font script="Gujr" typeface="Shruti"/>
+        <a:font script="Khmr" typeface="MoolBoran"/>
+        <a:font script="Knda" typeface="Tunga"/>
+        <a:font script="Guru" typeface="Raavi"/>
+        <a:font script="Cans" typeface="Euphemia"/>
+        <a:font script="Cher" typeface="Plantagenet Cherokee"/>
+        <a:font script="Yiii" typeface="Microsoft Yi Baiti"/>
+        <a:font script="Tibt" typeface="Microsoft Himalaya"/>
+        <a:font script="Thaa" typeface="MV Boli"/>
+        <a:font script="Deva" typeface="Mangal"/>
+        <a:font script="Telu" typeface="Gautami"/>
+        <a:font script="Taml" typeface="Latha"/>
+        <a:font script="Syrc" typeface="Estrangelo Edessa"/>
+        <a:font script="Orya" typeface="Kalinga"/>
+        <a:font script="Mlym" typeface="Kartika"/>
+        <a:font script="Laoo" typeface="DokChampa"/>
+        <a:font script="Sinh" typeface="Iskoola Pota"/>
+        <a:font script="Mong" typeface="Mongolian Baiti"/>
+        <a:font script="Viet" typeface="Times New Roman"/>
+        <a:font script="Uigh" typeface="Microsoft Uighur"/>
+        <a:font script="Geor" typeface="Sylfaen"/>
+      </a:majorFont>
+      <a:minorFont>
+        <a:latin typeface="Calibri"/>
+        <a:ea typeface=""/>
+        <a:cs typeface=""/>
+        <a:font script="Jpan" typeface="ＭＳ Ｐゴシック"/>
+        <a:font script="Hang" typeface="맑은 고딕"/>
+        <a:font script="Hans" typeface="宋体"/>
+        <a:font script="Hant" typeface="新細明體"/>
+        <a:font script="Arab" typeface="Arial"/>
+        <a:font script="Hebr" typeface="Arial"/>
+        <a:font script="Thai" typeface="Cordia New"/>
+        <a:font script="Ethi" typeface="Nyala"/>
+        <a:font script="Beng" typeface="Vrinda"/>
+        <a:font script="Gujr" typeface="Shruti"/>
+        <a:font script="Khmr" typeface="DaunPenh"/>
+        <a:font script="Knda" typeface="Tunga"/>
+        <a:font script="Guru" typeface="Raavi"/>
+        <a:font script="Cans" typeface="Euphemia"/>
+        <a:font script="Cher" typeface="Plantagenet Cherokee"/>
+        <a:font script="Yiii" typeface="Microsoft Yi Baiti"/>
+        <a:font script="Tibt" typeface="Microsoft Himalaya"/>
+        <a:font script="Thaa" typeface="MV Boli"/>
+        <a:font script="Deva" typeface="Mangal"/>
+        <a:font script="Telu" typeface="Gautami"/>
+        <a:font script="Taml" typeface="Latha"/>
+        <a:font script="Syrc" typeface="Estrangelo Edessa"/>
+        <a:font script="Orya" typeface="Kalinga"/>
+        <a:font script="Mlym" typeface="Kartika"/>
+        <a:font script="Laoo" typeface="DokChampa"/>
+        <a:font script="Sinh" typeface="Iskoola Pota"/>
+        <a:font script="Mong" typeface="Mongolian Baiti"/>
+        <a:font script="Viet" typeface="Arial"/>
+        <a:font script="Uigh" typeface="Microsoft Uighur"/>
+        <a:font script="Geor" typeface="Sylfaen"/>
+      </a:minorFont>
+    </a:fontScheme>
+    <a:fmtScheme name="Office">
+      <a:fillStyleLst>
+        <a:solidFill>
+          <a:schemeClr val="phClr"/>
+        </a:solidFill>
+        <a:gradFill rotWithShape="1">
+          <a:gsLst>
+            <a:gs pos="0">
+              <a:schemeClr val="phClr">
+                <a:tint val="50000"/>
+                <a:satMod val="300000"/>
+              </a:schemeClr>
+            </a:gs>
+            <a:gs pos="35000">
+              <a:schemeClr val="phClr">
+                <a:tint val="37000"/>
+                <a:satMod val="300000"/>
+              </a:schemeClr>
+            </a:gs>
+            <a:gs pos="100000">
+              <a:schemeClr val="phClr">
+                <a:tint val="15000"/>
+                <a:satMod val="350000"/>
+              </a:schemeClr>
+            </a:gs>
+          </a:gsLst>
+          <a:lin ang="16200000" scaled="1"/>
+        </a:gradFill>
+        <a:gradFill rotWithShape="1">
+          <a:gsLst>
+            <a:gs pos="0">
+              <a:schemeClr val="phClr">
+                <a:tint val="100000"/>
+                <a:shade val="100000"/>
+                <a:satMod val="130000"/>
+              </a:schemeClr>
+            </a:gs>
+            <a:gs pos="100000">
+              <a:schemeClr val="phClr">
+                <a:tint val="50000"/>
+                <a:shade val="100000"/>
+                <a:satMod val="350000"/>
+              </a:schemeClr>
+            </a:gs>
+          </a:gsLst>
+          <a:lin ang="16200000" scaled="0"/>
+        </a:gradFill>
+      </a:fillStyleLst>
+      <a:lnStyleLst>
+        <a:ln w="9525" cap="flat" cmpd="sng" algn="ctr">
+          <a:solidFill>
+            <a:schemeClr val="phClr">
+              <a:shade val="95000"/>
+              <a:satMod val="105000"/>
+            </a:schemeClr>
+          </a:solidFill>
+          <a:prstDash val="solid"/>
+        </a:ln>
+        <a:ln w="25400" cap="flat" cmpd="sng" algn="ctr">
+          <a:solidFill>
+            <a:schemeClr val="phClr"/>
+          </a:solidFill>
+          <a:prstDash val="solid"/>
+        </a:ln>
+        <a:ln w="38100" cap="flat" cmpd="sng" algn="ctr">
+          <a:solidFill>
+            <a:schemeClr val="phClr"/>
+          </a:solidFill>
+          <a:prstDash val="solid"/>
+        </a:ln>
+      </a:lnStyleLst>
+      <a:effectStyleLst>
+        <a:effectStyle>
+          <a:effectLst>
+            <a:outerShdw blurRad="40000" dist="20000" dir="5400000" rotWithShape="0">
+              <a:srgbClr val="000000">
+                <a:alpha val="38000"/>
+              </a:srgbClr>
+            </a:outerShdw>
+          </a:effectLst>
+        </a:effectStyle>
+        <a:effectStyle>
+          <a:effectLst>
+            <a:outerShdw blurRad="40000" dist="23000" dir="5400000" rotWithShape="0">
+              <a:srgbClr val="000000">
+                <a:alpha val="35000"/>
+              </a:srgbClr>
+            </a:outerShdw>
+          </a:effectLst>
+        </a:effectStyle>
+        <a:effectStyle>
+          <a:effectLst>
+            <a:outerShdw blurRad="40000" dist="23000" dir="5400000" rotWithShape="0">
+              <a:srgbClr val="000000">
+                <a:alpha val="35000"/>
+              </a:srgbClr>
+            </a:outerShdw>
+          </a:effectLst>
+          <a:scene3d>
+            <a:camera prst="orthographicFront">
+              <a:rot lat="0" lon="0" rev="0"/>
+            </a:camera>
+            <a:lightRig rig="threePt" dir="t">
+              <a:rot lat="0" lon="0" rev="1200000"/>
+            </a:lightRig>
+          </a:scene3d>
+          <a:sp3d>
+            <a:bevelT w="63500" h="25400"/>
+          </a:sp3d>
+        </a:effectStyle>
+      </a:effectStyleLst>
+      <a:bgFillStyleLst>
+        <a:solidFill>
+          <a:schemeClr val="phClr"/>
+        </a:solidFill>
+        <a:gradFill rotWithShape="1">
+          <a:gsLst>
+            <a:gs pos="0">
+              <a:schemeClr val="phClr">
+                <a:tint val="40000"/>
+                <a:satMod val="350000"/>
+              </a:schemeClr>
+            </a:gs>
+            <a:gs pos="40000">
+              <a:schemeClr val="phClr">
+                <a:tint val="45000"/>
+                <a:shade val="99000"/>
+                <a:satMod val="350000"/>
+              </a:schemeClr>
+            </a:gs>
+            <a:gs pos="100000">
+              <a:schemeClr val="phClr">
+                <a:shade val="20000"/>
+                <a:satMod val="255000"/>
+              </a:schemeClr>
+            </a:gs>
+          </a:gsLst>
+          <a:path path="circle">
+            <a:fillToRect l="50000" t="-80000" r="50000" b="180000"/>
+          </a:path>
+        </a:gradFill>
+        <a:gradFill rotWithShape="1">
+          <a:gsLst>
+            <a:gs pos="0">
+              <a:schemeClr val="phClr">
+                <a:tint val="80000"/>
+                <a:satMod val="300000"/>
+              </a:schemeClr>
+            </a:gs>
+            <a:gs pos="100000">
+              <a:schemeClr val="phClr">
+                <a:shade val="30000"/>
+                <a:satMod val="200000"/>
+              </a:schemeClr>
+            </a:gs>
+          </a:gsLst>
+          <a:path path="circle">
+            <a:fillToRect l="50000" t="50000" r="50000" b="50000"/>
+          </a:path>
+        </a:gradFill>
+      </a:bgFillStyleLst>
+    </a:fmtScheme>
+  </a:themeElements>
+  <a:objectDefaults>
+    <a:spDef>
+      <a:spPr/>
+      <a:bodyPr/>
+      <a:lstStyle/>
+      <a:style>
+        <a:lnRef idx="1">
+          <a:schemeClr val="accent1"/>
+        </a:lnRef>
+        <a:fillRef idx="3">
+          <a:schemeClr val="accent1"/>
+        </a:fillRef>
+        <a:effectRef idx="2">
+          <a:schemeClr val="accent1"/>
+        </a:effectRef>
+        <a:fontRef idx="minor">
+          <a:schemeClr val="lt1"/>
+        </a:fontRef>
+      </a:style>
+    </a:spDef>
+    <a:lnDef>
+      <a:spPr/>
+      <a:bodyPr/>
+      <a:lstStyle/>
+      <a:style>
+        <a:lnRef idx="2">
+          <a:schemeClr val="accent1"/>
+        </a:lnRef>
+        <a:fillRef idx="0">
+          <a:schemeClr val="accent1"/>
+        </a:fillRef>
+        <a:effectRef idx="1">
+          <a:schemeClr val="accent1"/>
+        </a:effectRef>
+        <a:fontRef idx="minor">
+          <a:schemeClr val="tx1"/>
+        </a:fontRef>
+      </a:style>
+    </a:lnDef>
+  </a:objectDefaults>
+  <a:extraClrSchemeLst/>
+</a:theme>
 </file>
</xml_diff>

<commit_message>
Enrich capability section and source evidence
</commit_message>
<xml_diff>
--- a/docs/zh/10-Claude Code 源码调研.pptx
+++ b/docs/zh/10-Claude Code 源码调研.pptx
@@ -8460,8 +8460,126 @@
         </p:nvSpPr>
         <p:spPr>
           <a:xfrm>
-            <a:off x="786384" y="5623560"/>
-            <a:ext cx="10789920" cy="594360"/>
+            <a:off x="5806440" y="4334256"/>
+            <a:ext cx="5715000" cy="1261872"/>
+          </a:xfrm>
+          <a:prstGeom prst="roundRect">
+            <a:avLst/>
+          </a:prstGeom>
+          <a:solidFill>
+            <a:srgbClr val="070F1F"/>
+          </a:solidFill>
+          <a:ln>
+            <a:solidFill>
+              <a:srgbClr val="48C6FF"/>
+            </a:solidFill>
+          </a:ln>
+        </p:spPr>
+        <p:style>
+          <a:lnRef idx="1">
+            <a:schemeClr val="accent1"/>
+          </a:lnRef>
+          <a:fillRef idx="3">
+            <a:schemeClr val="accent1"/>
+          </a:fillRef>
+          <a:effectRef idx="2">
+            <a:schemeClr val="accent1"/>
+          </a:effectRef>
+          <a:fontRef idx="minor">
+            <a:schemeClr val="lt1"/>
+          </a:fontRef>
+        </p:style>
+        <p:txBody>
+          <a:bodyPr rtlCol="0" anchor="t" wrap="square" tIns="177800" bIns="76200" lIns="127000" rIns="127000"/>
+          <a:lstStyle/>
+          <a:p>
+            <a:pPr algn="ctr"/>
+            <a:r>
+              <a:rPr sz="1050" b="0">
+                <a:solidFill>
+                  <a:srgbClr val="BEF6FF"/>
+                </a:solidFill>
+                <a:latin typeface="Courier New"/>
+              </a:rPr>
+              <a:t>export function getAllBaseTools(): Tools {
+  return [
+    AgentTool,
+    TaskOutputTool,
+    BashTool,
+    ...(hasEmbeddedSearchTools() ? [] : [GlobTool, GrepTool]),
+    ExitPlanModeV2Tool,
+    FileReadTool,
+    FileEditTool,
+    FileWriteTool,
+    ...
+  ]
+}</a:t>
+            </a:r>
+          </a:p>
+        </p:txBody>
+      </p:sp>
+      <p:sp>
+        <p:nvSpPr>
+          <p:cNvPr id="26" name="Rectangle 25"/>
+          <p:cNvSpPr/>
+          <p:nvPr/>
+        </p:nvSpPr>
+        <p:spPr>
+          <a:xfrm>
+            <a:off x="5806440" y="4334256"/>
+            <a:ext cx="5715000" cy="256032"/>
+          </a:xfrm>
+          <a:prstGeom prst="rect">
+            <a:avLst/>
+          </a:prstGeom>
+          <a:solidFill>
+            <a:srgbClr val="0E1F3F"/>
+          </a:solidFill>
+          <a:ln>
+            <a:noFill/>
+          </a:ln>
+        </p:spPr>
+        <p:style>
+          <a:lnRef idx="1">
+            <a:schemeClr val="accent1"/>
+          </a:lnRef>
+          <a:fillRef idx="3">
+            <a:schemeClr val="accent1"/>
+          </a:fillRef>
+          <a:effectRef idx="2">
+            <a:schemeClr val="accent1"/>
+          </a:effectRef>
+          <a:fontRef idx="minor">
+            <a:schemeClr val="lt1"/>
+          </a:fontRef>
+        </p:style>
+        <p:txBody>
+          <a:bodyPr rtlCol="0" anchor="t" wrap="square" tIns="25400" bIns="25400" lIns="76200" rIns="76200"/>
+          <a:lstStyle/>
+          <a:p>
+            <a:pPr algn="ctr"/>
+            <a:r>
+              <a:rPr sz="1000" b="1">
+                <a:solidFill>
+                  <a:srgbClr val="48C6FF"/>
+                </a:solidFill>
+                <a:latin typeface="Courier New"/>
+              </a:rPr>
+              <a:t>关键源码片段</a:t>
+            </a:r>
+          </a:p>
+        </p:txBody>
+      </p:sp>
+      <p:sp>
+        <p:nvSpPr>
+          <p:cNvPr id="27" name="Rounded Rectangle 26"/>
+          <p:cNvSpPr/>
+          <p:nvPr/>
+        </p:nvSpPr>
+        <p:spPr>
+          <a:xfrm>
+            <a:off x="786384" y="5687568"/>
+            <a:ext cx="10789920" cy="530352"/>
           </a:xfrm>
           <a:prstGeom prst="roundRect">
             <a:avLst/>
@@ -8499,13 +8617,13 @@
       </p:sp>
       <p:sp>
         <p:nvSpPr>
-          <p:cNvPr id="26" name="Rectangle 25"/>
-          <p:cNvSpPr/>
-          <p:nvPr/>
-        </p:nvSpPr>
-        <p:spPr>
-          <a:xfrm>
-            <a:off x="786384" y="5623560"/>
+          <p:cNvPr id="28" name="Rectangle 27"/>
+          <p:cNvSpPr/>
+          <p:nvPr/>
+        </p:nvSpPr>
+        <p:spPr>
+          <a:xfrm>
+            <a:off x="786384" y="5687568"/>
             <a:ext cx="10789920" cy="292608"/>
           </a:xfrm>
           <a:prstGeom prst="rect">
@@ -8551,14 +8669,14 @@
       </p:sp>
       <p:sp>
         <p:nvSpPr>
-          <p:cNvPr id="27" name="TextBox 26"/>
+          <p:cNvPr id="29" name="TextBox 28"/>
           <p:cNvSpPr txBox="1"/>
           <p:nvPr/>
         </p:nvSpPr>
         <p:spPr>
           <a:xfrm>
-            <a:off x="969264" y="5870448"/>
-            <a:ext cx="10378440" cy="182880"/>
+            <a:off x="969264" y="5888736"/>
+            <a:ext cx="10378440" cy="164592"/>
           </a:xfrm>
           <a:prstGeom prst="rect">
             <a:avLst/>
@@ -8590,7 +8708,7 @@
       </p:sp>
       <p:sp>
         <p:nvSpPr>
-          <p:cNvPr id="28" name="TextBox 27"/>
+          <p:cNvPr id="30" name="TextBox 29"/>
           <p:cNvSpPr txBox="1"/>
           <p:nvPr/>
         </p:nvSpPr>
@@ -9168,15 +9286,24 @@
                 </a:solidFill>
                 <a:latin typeface="Courier New"/>
               </a:rPr>
-              <a:t>case 'assistant':
-  this.mutableMessages.push(message)
-  yield* normalizeMessage(message)
-  break
-case 'progress':
-  this.mutableMessages.push(message)
+              <a:t>const COMMANDS = memoize((): Command[] =&gt; [
+  addDir,
+  advisor,
+  clear,
+  compact,
+  config,
+  context,
+  diff,
+  help,
+  login,
+  mcp,
+  plan,
+  plugin,
+  resume,
+  review,
+  tasks,
   ...
-  yield* normalizeMessage(message)
-  break</a:t>
+])</a:t>
             </a:r>
           </a:p>
         </p:txBody>
@@ -11174,7 +11301,12 @@
                 </a:solidFill>
                 <a:latin typeface="Courier New"/>
               </a:rPr>
-              <a:t>The user will primarily request you to perform software engineering tasks.</a:t>
+              <a:t>export function buildEffectiveSystemPrompt({
+  customSystemPrompt,
+  defaultSystemPrompt,
+  appendSystemPrompt,
+  overrideSystemPrompt,
+}: ...): SystemPrompt</a:t>
             </a:r>
           </a:p>
         </p:txBody>
@@ -12278,6 +12410,8 @@
               <a:t>type State = {
   messages: Message[]
   toolUseContext: ToolUseContext
+  autoCompactTracking: AutoCompactTrackingState | undefined
+  maxOutputTokensRecoveryCount: number
   pendingToolUseSummary: Promise&lt;ToolUseSummaryMessage | null&gt; | undefined
   stopHookActive: boolean | undefined
   turnCount: number

</xml_diff>